<commit_message>
The deck shows the site it actually builds
The hierarchy slide was a drawing of an org chart; it is now a screenshot of
the generated one, which is the whole point — nobody drew it. The checkpoint
shows the four-page dashboard with its tabs, the workflows checkpoint shows a
real department block with its counts, and step four mentions the one
question the installer asks.

Co-Authored-By: Claude Opus 5 <noreply@anthropic.com>
Claude-Session: https://claude.ai/code/session_01GU6RhWctnBpcS6dNZ87S1b
</commit_message>
<xml_diff>
--- a/docs/Architecture for Agents — a hands-on hour.pptx
+++ b/docs/Architecture for Agents — a hands-on hour.pptx
@@ -606,7 +606,7 @@
           <a:p>
             <a:r>
               <a:rPr lang="en-US" dirty="0"/>
-              <a:t>Do not try to read this from the projector — everyone has it on their own screen, full size. Hold the room until hands are down. If somebody's check is red, it will say why in plain language — read it out, it is a good advert for the next twenty minutes.</a:t>
+              <a:t>Do not try to read this from the projector — everyone has it on their own screen, full size. Hold the room until hands are down. If somebody's check is red it will say why in plain language: read it out, it is a good advert for the next twenty minutes.</a:t>
             </a:r>
             <a:endParaRPr lang="en-US" dirty="0"/>
           </a:p>
@@ -870,7 +870,7 @@
           <a:p>
             <a:r>
               <a:rPr lang="en-US" dirty="0"/>
-              <a:t>These four are an example — theirs will differ. Point at the Workflow Architect: it owns how a workflow gets written down, not what any hat does. It is the one role nobody thinks to create.</a:t>
+              <a:t>These names came from the Norse option at install — theirs will differ. Point at Bragi, across all departments: it owns how a workflow gets written down, not what any department does. It is the role nobody thinks to create.</a:t>
             </a:r>
             <a:endParaRPr lang="en-US" dirty="0"/>
           </a:p>
@@ -958,7 +958,7 @@
           <a:p>
             <a:r>
               <a:rPr lang="en-US" dirty="0"/>
-              <a:t>Point at the zero. That is the whole value proposition in one number — it is counted, not reported, so it cannot be quietly optimistic.</a:t>
+              <a:t>Point at the zero. That is the whole value proposition in one number — counted rather than reported, so it cannot be quietly optimistic. Ask the room how many of their own written processes would survive that column.</a:t>
             </a:r>
             <a:endParaRPr lang="en-US" dirty="0"/>
           </a:p>
@@ -1926,7 +1926,7 @@
           <a:p>
             <a:r>
               <a:rPr lang="en-US" dirty="0"/>
-              <a:t>Read the sentence out and put it in the chat so nobody mistypes the address. It takes about a minute. Tell them to watch the Obsidian pane while it runs — folders and notes appear one after another.</a:t>
+              <a:t>Read the sentence out and put it in the chat so nobody mistypes the address. The naming question is the one bit of fun in the install — let the room shout answers. It takes about a minute. Tell them to watch the Obsidian pane while it runs — folders and notes appear one after another.</a:t>
             </a:r>
             <a:endParaRPr lang="en-US" dirty="0"/>
           </a:p>
@@ -2664,7 +2664,7 @@
       </p:sp>
       <p:pic>
         <p:nvPicPr>
-          <p:cNvPr id="5" name="Image 1" descr="/tmp/claude-0/-home-claude/e62a35b1-5075-553d-b086-acebfebc41ba/scratchpad/deck/w-dayone.png">    </p:cNvPr>
+          <p:cNvPr id="5" name="Image 1" descr="/tmp/claude-0/-home-claude/e62a35b1-5075-553d-b086-acebfebc41ba/scratchpad/deck/k-dayone.png">    </p:cNvPr>
           <p:cNvPicPr>
             <a:picLocks noChangeAspect="1"/>
           </p:cNvPicPr>
@@ -2678,8 +2678,8 @@
         </p:blipFill>
         <p:spPr>
           <a:xfrm>
-            <a:off x="777240" y="1783080"/>
-            <a:ext cx="7589520" cy="4014216"/>
+            <a:off x="777240" y="1737360"/>
+            <a:ext cx="8138160" cy="4005072"/>
           </a:xfrm>
           <a:prstGeom prst="rect">
             <a:avLst/>
@@ -2694,12 +2694,12 @@
         </p:nvSpPr>
         <p:spPr>
           <a:xfrm>
-            <a:off x="8641080" y="1783080"/>
-            <a:ext cx="2743200" cy="1874520"/>
+            <a:off x="9189720" y="1737360"/>
+            <a:ext cx="2194560" cy="1920240"/>
           </a:xfrm>
           <a:prstGeom prst="roundRect">
             <a:avLst>
-              <a:gd name="adj" fmla="val 2927"/>
+              <a:gd name="adj" fmla="val 2857"/>
             </a:avLst>
           </a:prstGeom>
           <a:solidFill>
@@ -2721,8 +2721,8 @@
         </p:nvSpPr>
         <p:spPr>
           <a:xfrm>
-            <a:off x="8915400" y="2057400"/>
-            <a:ext cx="2194560" cy="329184"/>
+            <a:off x="9464040" y="2011680"/>
+            <a:ext cx="1645920" cy="329184"/>
           </a:xfrm>
           <a:prstGeom prst="rect">
             <a:avLst/>
@@ -2749,7 +2749,7 @@
                 <a:ea typeface="Public Sans" pitchFamily="34" charset="-122"/>
                 <a:cs typeface="Public Sans" pitchFamily="34" charset="-120"/>
               </a:rPr>
-              <a:t>Ask for it by name</a:t>
+              <a:t>Four pages</a:t>
             </a:r>
             <a:endParaRPr lang="en-US" sz="1500" dirty="0"/>
           </a:p>
@@ -2763,8 +2763,8 @@
         </p:nvSpPr>
         <p:spPr>
           <a:xfrm>
-            <a:off x="8915400" y="2478024"/>
-            <a:ext cx="2194560" cy="941832"/>
+            <a:off x="9464040" y="2432304"/>
+            <a:ext cx="1645920" cy="987552"/>
           </a:xfrm>
           <a:prstGeom prst="rect">
             <a:avLst/>
@@ -2791,7 +2791,7 @@
                 <a:ea typeface="Public Sans" pitchFamily="34" charset="-122"/>
                 <a:cs typeface="Public Sans" pitchFamily="34" charset="-120"/>
               </a:rPr>
-              <a:t>“Open the picture and tell me what it says.” It is a file in your own folder.</a:t>
+              <a:t>Dashboard, agent organization, workflows, projects — tabs across the top.</a:t>
             </a:r>
             <a:endParaRPr lang="en-US" sz="1250" dirty="0"/>
           </a:p>
@@ -2805,12 +2805,12 @@
         </p:nvSpPr>
         <p:spPr>
           <a:xfrm>
-            <a:off x="8641080" y="3968496"/>
-            <a:ext cx="2743200" cy="1874520"/>
+            <a:off x="9189720" y="3822192"/>
+            <a:ext cx="2194560" cy="1920240"/>
           </a:xfrm>
           <a:prstGeom prst="roundRect">
             <a:avLst>
-              <a:gd name="adj" fmla="val 2927"/>
+              <a:gd name="adj" fmla="val 2857"/>
             </a:avLst>
           </a:prstGeom>
           <a:solidFill>
@@ -2832,8 +2832,8 @@
         </p:nvSpPr>
         <p:spPr>
           <a:xfrm>
-            <a:off x="8915400" y="4242816"/>
-            <a:ext cx="2194560" cy="329184"/>
+            <a:off x="9464040" y="4096512"/>
+            <a:ext cx="1645920" cy="329184"/>
           </a:xfrm>
           <a:prstGeom prst="rect">
             <a:avLst/>
@@ -2860,7 +2860,7 @@
                 <a:ea typeface="Public Sans" pitchFamily="34" charset="-122"/>
                 <a:cs typeface="Public Sans" pitchFamily="34" charset="-120"/>
               </a:rPr>
-              <a:t>Nearly empty, and honest</a:t>
+              <a:t>Honest on day one</a:t>
             </a:r>
             <a:endParaRPr lang="en-US" sz="1500" dirty="0"/>
           </a:p>
@@ -2874,8 +2874,8 @@
         </p:nvSpPr>
         <p:spPr>
           <a:xfrm>
-            <a:off x="8915400" y="4663440"/>
-            <a:ext cx="2194560" cy="941832"/>
+            <a:off x="9464040" y="4517136"/>
+            <a:ext cx="1645920" cy="987552"/>
           </a:xfrm>
           <a:prstGeom prst="rect">
             <a:avLst/>
@@ -2902,7 +2902,7 @@
                 <a:ea typeface="Public Sans" pitchFamily="34" charset="-122"/>
                 <a:cs typeface="Public Sans" pitchFamily="34" charset="-120"/>
               </a:rPr>
-              <a:t>One example department, three roles. It does not pretend to be your job yet. Next step is where it becomes yours.</a:t>
+              <a:t>Two departments, three executives, and it says so. Not your job yet — that is next.</a:t>
             </a:r>
             <a:endParaRPr lang="en-US" sz="1250" dirty="0"/>
           </a:p>
@@ -4372,7 +4372,7 @@
         </p:nvSpPr>
         <p:spPr>
           <a:xfrm>
-            <a:off x="777240" y="1783080"/>
+            <a:off x="777240" y="1572768"/>
             <a:ext cx="10637215" cy="566928"/>
           </a:xfrm>
           <a:prstGeom prst="rect">
@@ -4400,236 +4400,58 @@
                 <a:ea typeface="Public Sans" pitchFamily="34" charset="-122"/>
                 <a:cs typeface="Public Sans" pitchFamily="34" charset="-120"/>
               </a:rPr>
-              <a:t>Each department note compiles into an assistant that answers for that department and nothing else. Adding one next month is the same sentence again.</a:t>
+              <a:t>Nobody drew this. It is read off each role note — who it reports to, which department it answers for — and redrawn every time the site is built.</a:t>
             </a:r>
             <a:endParaRPr lang="en-US" sz="1500" dirty="0"/>
           </a:p>
         </p:txBody>
       </p:sp>
-      <p:sp>
-        <p:nvSpPr>
-          <p:cNvPr id="6" name="Shape 3"/>
+      <p:pic>
+        <p:nvPicPr>
+          <p:cNvPr id="6" name="Image 1" descr="/tmp/claude-0/-home-claude/e62a35b1-5075-553d-b086-acebfebc41ba/scratchpad/deck/k-org.png">    </p:cNvPr>
+          <p:cNvPicPr>
+            <a:picLocks noChangeAspect="1"/>
+          </p:cNvPicPr>
+          <p:nvPr/>
+        </p:nvPicPr>
+        <p:blipFill>
+          <a:blip r:embed="rId2"/>
+          <a:stretch>
+            <a:fillRect/>
+          </a:stretch>
+        </p:blipFill>
+        <p:spPr>
+          <a:xfrm>
+            <a:off x="1252728" y="2148840"/>
+            <a:ext cx="9692640" cy="3099816"/>
+          </a:xfrm>
+          <a:prstGeom prst="rect">
+            <a:avLst/>
+          </a:prstGeom>
+        </p:spPr>
+      </p:pic>
+      <p:sp>
+        <p:nvSpPr>
+          <p:cNvPr id="7" name="Shape 3"/>
           <p:cNvSpPr/>
           <p:nvPr/>
         </p:nvSpPr>
         <p:spPr>
           <a:xfrm>
-            <a:off x="4678528" y="2606040"/>
-            <a:ext cx="2834640" cy="566928"/>
+            <a:off x="777240" y="5440680"/>
+            <a:ext cx="10607040" cy="566928"/>
           </a:xfrm>
           <a:prstGeom prst="roundRect">
             <a:avLst>
-              <a:gd name="adj" fmla="val 12903"/>
-            </a:avLst>
-          </a:prstGeom>
-          <a:solidFill>
-            <a:srgbClr val="15171F"/>
-          </a:solidFill>
-          <a:ln/>
-        </p:spPr>
-      </p:sp>
-      <p:sp>
-        <p:nvSpPr>
-          <p:cNvPr id="7" name="Text 4"/>
-          <p:cNvSpPr txBox="1"/>
-          <p:nvPr/>
-        </p:nvSpPr>
-        <p:spPr>
-          <a:xfrm>
-            <a:off x="4678528" y="2606040"/>
-            <a:ext cx="2834640" cy="566928"/>
-          </a:xfrm>
-          <a:prstGeom prst="rect">
-            <a:avLst/>
-          </a:prstGeom>
-          <a:noFill/>
-          <a:ln/>
-        </p:spPr>
-        <p:txBody>
-          <a:bodyPr wrap="square" lIns="0" tIns="0" rIns="0" bIns="0" rtlCol="0" anchor="ctr"/>
-          <a:lstStyle/>
-          <a:p>
-            <a:pPr algn="ctr" indent="0" marL="0">
-              <a:buNone/>
-            </a:pPr>
-            <a:r>
-              <a:rPr lang="en-US" sz="1500" b="1" dirty="0">
-                <a:solidFill>
-                  <a:srgbClr val="FFFFFF"/>
-                </a:solidFill>
-                <a:latin typeface="Public Sans" pitchFamily="34" charset="0"/>
-                <a:ea typeface="Public Sans" pitchFamily="34" charset="-122"/>
-                <a:cs typeface="Public Sans" pitchFamily="34" charset="-120"/>
-              </a:rPr>
-              <a:t>You</a:t>
-            </a:r>
-            <a:endParaRPr lang="en-US" sz="1500" dirty="0"/>
-          </a:p>
-        </p:txBody>
-      </p:sp>
-      <p:sp>
-        <p:nvSpPr>
-          <p:cNvPr id="8" name="Shape 5"/>
-          <p:cNvSpPr/>
-          <p:nvPr/>
-        </p:nvSpPr>
-        <p:spPr>
-          <a:xfrm>
-            <a:off x="4678528" y="3429000"/>
-            <a:ext cx="2834640" cy="566928"/>
-          </a:xfrm>
-          <a:prstGeom prst="roundRect">
-            <a:avLst>
-              <a:gd name="adj" fmla="val 12903"/>
-            </a:avLst>
-          </a:prstGeom>
-          <a:solidFill>
-            <a:srgbClr val="7367F0"/>
-          </a:solidFill>
-          <a:ln/>
-        </p:spPr>
-      </p:sp>
-      <p:sp>
-        <p:nvSpPr>
-          <p:cNvPr id="9" name="Text 6"/>
-          <p:cNvSpPr txBox="1"/>
-          <p:nvPr/>
-        </p:nvSpPr>
-        <p:spPr>
-          <a:xfrm>
-            <a:off x="4678528" y="3429000"/>
-            <a:ext cx="2834640" cy="566928"/>
-          </a:xfrm>
-          <a:prstGeom prst="rect">
-            <a:avLst/>
-          </a:prstGeom>
-          <a:noFill/>
-          <a:ln/>
-        </p:spPr>
-        <p:txBody>
-          <a:bodyPr wrap="square" lIns="0" tIns="0" rIns="0" bIns="0" rtlCol="0" anchor="ctr"/>
-          <a:lstStyle/>
-          <a:p>
-            <a:pPr algn="ctr" indent="0" marL="0">
-              <a:buNone/>
-            </a:pPr>
-            <a:r>
-              <a:rPr lang="en-US" sz="1500" b="1" dirty="0">
-                <a:solidFill>
-                  <a:srgbClr val="FFFFFF"/>
-                </a:solidFill>
-                <a:latin typeface="Public Sans" pitchFamily="34" charset="0"/>
-                <a:ea typeface="Public Sans" pitchFamily="34" charset="-122"/>
-                <a:cs typeface="Public Sans" pitchFamily="34" charset="-120"/>
-              </a:rPr>
-              <a:t>Chief of Staff</a:t>
-            </a:r>
-            <a:endParaRPr lang="en-US" sz="1500" dirty="0"/>
-          </a:p>
-        </p:txBody>
-      </p:sp>
-      <p:sp>
-        <p:nvSpPr>
-          <p:cNvPr id="10" name="Shape 7"/>
-          <p:cNvSpPr/>
-          <p:nvPr/>
-        </p:nvSpPr>
-        <p:spPr>
-          <a:xfrm>
-            <a:off x="6084418" y="3172968"/>
-            <a:ext cx="22860" cy="256032"/>
-          </a:xfrm>
-          <a:prstGeom prst="rect">
-            <a:avLst/>
-          </a:prstGeom>
-          <a:solidFill>
-            <a:srgbClr val="C9CDD6"/>
-          </a:solidFill>
-          <a:ln/>
-        </p:spPr>
-      </p:sp>
-      <p:sp>
-        <p:nvSpPr>
-          <p:cNvPr id="11" name="Shape 8"/>
-          <p:cNvSpPr/>
-          <p:nvPr/>
-        </p:nvSpPr>
-        <p:spPr>
-          <a:xfrm>
-            <a:off x="6084418" y="3995928"/>
-            <a:ext cx="22860" cy="292608"/>
-          </a:xfrm>
-          <a:prstGeom prst="rect">
-            <a:avLst/>
-          </a:prstGeom>
-          <a:solidFill>
-            <a:srgbClr val="C9CDD6"/>
-          </a:solidFill>
-          <a:ln/>
-        </p:spPr>
-      </p:sp>
-      <p:sp>
-        <p:nvSpPr>
-          <p:cNvPr id="12" name="Shape 9"/>
-          <p:cNvSpPr/>
-          <p:nvPr/>
-        </p:nvSpPr>
-        <p:spPr>
-          <a:xfrm>
-            <a:off x="1798168" y="4279392"/>
-            <a:ext cx="8595360" cy="22860"/>
-          </a:xfrm>
-          <a:prstGeom prst="rect">
-            <a:avLst/>
-          </a:prstGeom>
-          <a:solidFill>
-            <a:srgbClr val="C9CDD6"/>
-          </a:solidFill>
-          <a:ln/>
-        </p:spPr>
-      </p:sp>
-      <p:sp>
-        <p:nvSpPr>
-          <p:cNvPr id="13" name="Shape 10"/>
-          <p:cNvSpPr/>
-          <p:nvPr/>
-        </p:nvSpPr>
-        <p:spPr>
-          <a:xfrm>
-            <a:off x="1786738" y="4279392"/>
-            <a:ext cx="22860" cy="274320"/>
-          </a:xfrm>
-          <a:prstGeom prst="rect">
-            <a:avLst/>
-          </a:prstGeom>
-          <a:solidFill>
-            <a:srgbClr val="C9CDD6"/>
-          </a:solidFill>
-          <a:ln/>
-        </p:spPr>
-      </p:sp>
-      <p:sp>
-        <p:nvSpPr>
-          <p:cNvPr id="14" name="Shape 11"/>
-          <p:cNvSpPr/>
-          <p:nvPr/>
-        </p:nvSpPr>
-        <p:spPr>
-          <a:xfrm>
-            <a:off x="838048" y="4553712"/>
-            <a:ext cx="1920240" cy="841248"/>
-          </a:xfrm>
-          <a:prstGeom prst="roundRect">
-            <a:avLst>
-              <a:gd name="adj" fmla="val 8696"/>
+              <a:gd name="adj" fmla="val 9677"/>
             </a:avLst>
           </a:prstGeom>
           <a:solidFill>
             <a:srgbClr val="F4F5F8"/>
           </a:solidFill>
-          <a:ln w="17780">
+          <a:ln w="12700">
             <a:solidFill>
-              <a:srgbClr val="C4BDFF"/>
+              <a:srgbClr val="E4E6EC"/>
             </a:solidFill>
             <a:prstDash val="solid"/>
           </a:ln>
@@ -4637,33 +4459,30 @@
       </p:sp>
       <p:sp>
         <p:nvSpPr>
-          <p:cNvPr id="15" name="Text 12"/>
-          <p:cNvSpPr txBox="1"/>
-          <p:nvPr/>
-        </p:nvSpPr>
-        <p:spPr>
-          <a:xfrm>
-            <a:off x="838048" y="4553712"/>
-            <a:ext cx="1920240" cy="841248"/>
-          </a:xfrm>
-          <a:prstGeom prst="rect">
-            <a:avLst/>
-          </a:prstGeom>
-          <a:noFill/>
-          <a:ln/>
-        </p:spPr>
-        <p:txBody>
-          <a:bodyPr wrap="square" lIns="0" tIns="0" rIns="0" bIns="0" rtlCol="0" anchor="ctr"/>
-          <a:lstStyle/>
-          <a:p>
-            <a:pPr algn="ctr" indent="0" marL="0">
-              <a:lnSpc>
-                <a:spcPts val="1700"/>
-              </a:lnSpc>
-              <a:buNone/>
-            </a:pPr>
-            <a:r>
-              <a:rPr lang="en-US" sz="1350" b="1" dirty="0">
+          <p:cNvPr id="8" name="Text 4"/>
+          <p:cNvSpPr txBox="1"/>
+          <p:nvPr/>
+        </p:nvSpPr>
+        <p:spPr>
+          <a:xfrm>
+            <a:off x="1097280" y="5440680"/>
+            <a:ext cx="10058400" cy="566928"/>
+          </a:xfrm>
+          <a:prstGeom prst="rect">
+            <a:avLst/>
+          </a:prstGeom>
+          <a:noFill/>
+          <a:ln/>
+        </p:spPr>
+        <p:txBody>
+          <a:bodyPr wrap="square" lIns="0" tIns="0" rIns="0" bIns="0" rtlCol="0" anchor="ctr"/>
+          <a:lstStyle/>
+          <a:p>
+            <a:pPr indent="0" marL="0">
+              <a:buNone/>
+            </a:pPr>
+            <a:r>
+              <a:rPr lang="en-US" sz="1400" b="1" dirty="0">
                 <a:solidFill>
                   <a:srgbClr val="15171F"/>
                 </a:solidFill>
@@ -4671,470 +4490,29 @@
                 <a:ea typeface="Public Sans" pitchFamily="34" charset="-122"/>
                 <a:cs typeface="Public Sans" pitchFamily="34" charset="-120"/>
               </a:rPr>
-              <a:t>Client</a:t>
-            </a:r>
-            <a:endParaRPr lang="en-US" sz="1350" dirty="0"/>
-          </a:p>
-          <a:p>
-            <a:pPr algn="ctr" indent="0" marL="0">
-              <a:lnSpc>
-                <a:spcPts val="1700"/>
-              </a:lnSpc>
-              <a:buNone/>
-            </a:pPr>
-            <a:r>
-              <a:rPr lang="en-US" sz="1350" b="1" dirty="0">
-                <a:solidFill>
-                  <a:srgbClr val="15171F"/>
-                </a:solidFill>
-                <a:latin typeface="Public Sans" pitchFamily="34" charset="0"/>
-                <a:ea typeface="Public Sans" pitchFamily="34" charset="-122"/>
-                <a:cs typeface="Public Sans" pitchFamily="34" charset="-120"/>
-              </a:rPr>
-              <a:t>Work</a:t>
-            </a:r>
-            <a:endParaRPr lang="en-US" sz="1350" dirty="0"/>
-          </a:p>
-        </p:txBody>
-      </p:sp>
-      <p:sp>
-        <p:nvSpPr>
-          <p:cNvPr id="16" name="Shape 13"/>
-          <p:cNvSpPr/>
-          <p:nvPr/>
-        </p:nvSpPr>
-        <p:spPr>
-          <a:xfrm>
-            <a:off x="3935578" y="4279392"/>
-            <a:ext cx="22860" cy="274320"/>
-          </a:xfrm>
-          <a:prstGeom prst="rect">
-            <a:avLst/>
-          </a:prstGeom>
-          <a:solidFill>
-            <a:srgbClr val="C9CDD6"/>
-          </a:solidFill>
-          <a:ln/>
-        </p:spPr>
-      </p:sp>
-      <p:sp>
-        <p:nvSpPr>
-          <p:cNvPr id="17" name="Shape 14"/>
-          <p:cNvSpPr/>
-          <p:nvPr/>
-        </p:nvSpPr>
-        <p:spPr>
-          <a:xfrm>
-            <a:off x="2986888" y="4553712"/>
-            <a:ext cx="1920240" cy="841248"/>
-          </a:xfrm>
-          <a:prstGeom prst="roundRect">
-            <a:avLst>
-              <a:gd name="adj" fmla="val 8696"/>
-            </a:avLst>
-          </a:prstGeom>
-          <a:solidFill>
-            <a:srgbClr val="F4F5F8"/>
-          </a:solidFill>
-          <a:ln w="17780">
-            <a:solidFill>
-              <a:srgbClr val="C4BDFF"/>
-            </a:solidFill>
-            <a:prstDash val="solid"/>
-          </a:ln>
-        </p:spPr>
-      </p:sp>
-      <p:sp>
-        <p:nvSpPr>
-          <p:cNvPr id="18" name="Text 15"/>
-          <p:cNvSpPr txBox="1"/>
-          <p:nvPr/>
-        </p:nvSpPr>
-        <p:spPr>
-          <a:xfrm>
-            <a:off x="2986888" y="4553712"/>
-            <a:ext cx="1920240" cy="841248"/>
-          </a:xfrm>
-          <a:prstGeom prst="rect">
-            <a:avLst/>
-          </a:prstGeom>
-          <a:noFill/>
-          <a:ln/>
-        </p:spPr>
-        <p:txBody>
-          <a:bodyPr wrap="square" lIns="0" tIns="0" rIns="0" bIns="0" rtlCol="0" anchor="ctr"/>
-          <a:lstStyle/>
-          <a:p>
-            <a:pPr algn="ctr" indent="0" marL="0">
-              <a:lnSpc>
-                <a:spcPts val="1700"/>
-              </a:lnSpc>
-              <a:buNone/>
-            </a:pPr>
-            <a:r>
-              <a:rPr lang="en-US" sz="1350" b="1" dirty="0">
-                <a:solidFill>
-                  <a:srgbClr val="15171F"/>
-                </a:solidFill>
-                <a:latin typeface="Public Sans" pitchFamily="34" charset="0"/>
-                <a:ea typeface="Public Sans" pitchFamily="34" charset="-122"/>
-                <a:cs typeface="Public Sans" pitchFamily="34" charset="-120"/>
-              </a:rPr>
-              <a:t>Delivery</a:t>
-            </a:r>
-            <a:endParaRPr lang="en-US" sz="1350" dirty="0"/>
-          </a:p>
-        </p:txBody>
-      </p:sp>
-      <p:sp>
-        <p:nvSpPr>
-          <p:cNvPr id="19" name="Shape 16"/>
-          <p:cNvSpPr/>
-          <p:nvPr/>
-        </p:nvSpPr>
-        <p:spPr>
-          <a:xfrm>
-            <a:off x="6084418" y="4279392"/>
-            <a:ext cx="22860" cy="274320"/>
-          </a:xfrm>
-          <a:prstGeom prst="rect">
-            <a:avLst/>
-          </a:prstGeom>
-          <a:solidFill>
-            <a:srgbClr val="C9CDD6"/>
-          </a:solidFill>
-          <a:ln/>
-        </p:spPr>
-      </p:sp>
-      <p:sp>
-        <p:nvSpPr>
-          <p:cNvPr id="20" name="Shape 17"/>
-          <p:cNvSpPr/>
-          <p:nvPr/>
-        </p:nvSpPr>
-        <p:spPr>
-          <a:xfrm>
-            <a:off x="5135728" y="4553712"/>
-            <a:ext cx="1920240" cy="841248"/>
-          </a:xfrm>
-          <a:prstGeom prst="roundRect">
-            <a:avLst>
-              <a:gd name="adj" fmla="val 8696"/>
-            </a:avLst>
-          </a:prstGeom>
-          <a:solidFill>
-            <a:srgbClr val="F4F5F8"/>
-          </a:solidFill>
-          <a:ln w="17780">
-            <a:solidFill>
-              <a:srgbClr val="C4BDFF"/>
-            </a:solidFill>
-            <a:prstDash val="solid"/>
-          </a:ln>
-        </p:spPr>
-      </p:sp>
-      <p:sp>
-        <p:nvSpPr>
-          <p:cNvPr id="21" name="Text 18"/>
-          <p:cNvSpPr txBox="1"/>
-          <p:nvPr/>
-        </p:nvSpPr>
-        <p:spPr>
-          <a:xfrm>
-            <a:off x="5135728" y="4553712"/>
-            <a:ext cx="1920240" cy="841248"/>
-          </a:xfrm>
-          <a:prstGeom prst="rect">
-            <a:avLst/>
-          </a:prstGeom>
-          <a:noFill/>
-          <a:ln/>
-        </p:spPr>
-        <p:txBody>
-          <a:bodyPr wrap="square" lIns="0" tIns="0" rIns="0" bIns="0" rtlCol="0" anchor="ctr"/>
-          <a:lstStyle/>
-          <a:p>
-            <a:pPr algn="ctr" indent="0" marL="0">
-              <a:lnSpc>
-                <a:spcPts val="1700"/>
-              </a:lnSpc>
-              <a:buNone/>
-            </a:pPr>
-            <a:r>
-              <a:rPr lang="en-US" sz="1350" b="1" dirty="0">
-                <a:solidFill>
-                  <a:srgbClr val="15171F"/>
-                </a:solidFill>
-                <a:latin typeface="Public Sans" pitchFamily="34" charset="0"/>
-                <a:ea typeface="Public Sans" pitchFamily="34" charset="-122"/>
-                <a:cs typeface="Public Sans" pitchFamily="34" charset="-120"/>
-              </a:rPr>
-              <a:t>LinkedIn</a:t>
-            </a:r>
-            <a:endParaRPr lang="en-US" sz="1350" dirty="0"/>
-          </a:p>
-          <a:p>
-            <a:pPr algn="ctr" indent="0" marL="0">
-              <a:lnSpc>
-                <a:spcPts val="1700"/>
-              </a:lnSpc>
-              <a:buNone/>
-            </a:pPr>
-            <a:r>
-              <a:rPr lang="en-US" sz="1350" b="1" dirty="0">
-                <a:solidFill>
-                  <a:srgbClr val="15171F"/>
-                </a:solidFill>
-                <a:latin typeface="Public Sans" pitchFamily="34" charset="0"/>
-                <a:ea typeface="Public Sans" pitchFamily="34" charset="-122"/>
-                <a:cs typeface="Public Sans" pitchFamily="34" charset="-120"/>
-              </a:rPr>
-              <a:t>&amp; Social</a:t>
-            </a:r>
-            <a:endParaRPr lang="en-US" sz="1350" dirty="0"/>
-          </a:p>
-        </p:txBody>
-      </p:sp>
-      <p:sp>
-        <p:nvSpPr>
-          <p:cNvPr id="22" name="Shape 19"/>
-          <p:cNvSpPr/>
-          <p:nvPr/>
-        </p:nvSpPr>
-        <p:spPr>
-          <a:xfrm>
-            <a:off x="8233258" y="4279392"/>
-            <a:ext cx="22860" cy="274320"/>
-          </a:xfrm>
-          <a:prstGeom prst="rect">
-            <a:avLst/>
-          </a:prstGeom>
-          <a:solidFill>
-            <a:srgbClr val="C9CDD6"/>
-          </a:solidFill>
-          <a:ln/>
-        </p:spPr>
-      </p:sp>
-      <p:sp>
-        <p:nvSpPr>
-          <p:cNvPr id="23" name="Shape 20"/>
-          <p:cNvSpPr/>
-          <p:nvPr/>
-        </p:nvSpPr>
-        <p:spPr>
-          <a:xfrm>
-            <a:off x="7284568" y="4553712"/>
-            <a:ext cx="1920240" cy="841248"/>
-          </a:xfrm>
-          <a:prstGeom prst="roundRect">
-            <a:avLst>
-              <a:gd name="adj" fmla="val 8696"/>
-            </a:avLst>
-          </a:prstGeom>
-          <a:solidFill>
-            <a:srgbClr val="F4F5F8"/>
-          </a:solidFill>
-          <a:ln w="17780">
-            <a:solidFill>
-              <a:srgbClr val="C4BDFF"/>
-            </a:solidFill>
-            <a:prstDash val="solid"/>
-          </a:ln>
-        </p:spPr>
-      </p:sp>
-      <p:sp>
-        <p:nvSpPr>
-          <p:cNvPr id="24" name="Text 21"/>
-          <p:cNvSpPr txBox="1"/>
-          <p:nvPr/>
-        </p:nvSpPr>
-        <p:spPr>
-          <a:xfrm>
-            <a:off x="7284568" y="4553712"/>
-            <a:ext cx="1920240" cy="841248"/>
-          </a:xfrm>
-          <a:prstGeom prst="rect">
-            <a:avLst/>
-          </a:prstGeom>
-          <a:noFill/>
-          <a:ln/>
-        </p:spPr>
-        <p:txBody>
-          <a:bodyPr wrap="square" lIns="0" tIns="0" rIns="0" bIns="0" rtlCol="0" anchor="ctr"/>
-          <a:lstStyle/>
-          <a:p>
-            <a:pPr algn="ctr" indent="0" marL="0">
-              <a:lnSpc>
-                <a:spcPts val="1700"/>
-              </a:lnSpc>
-              <a:buNone/>
-            </a:pPr>
-            <a:r>
-              <a:rPr lang="en-US" sz="1350" b="1" dirty="0">
-                <a:solidFill>
-                  <a:srgbClr val="15171F"/>
-                </a:solidFill>
-                <a:latin typeface="Public Sans" pitchFamily="34" charset="0"/>
-                <a:ea typeface="Public Sans" pitchFamily="34" charset="-122"/>
-                <a:cs typeface="Public Sans" pitchFamily="34" charset="-120"/>
-              </a:rPr>
-              <a:t>Reporting</a:t>
-            </a:r>
-            <a:endParaRPr lang="en-US" sz="1350" dirty="0"/>
-          </a:p>
-        </p:txBody>
-      </p:sp>
-      <p:sp>
-        <p:nvSpPr>
-          <p:cNvPr id="25" name="Shape 22"/>
-          <p:cNvSpPr/>
-          <p:nvPr/>
-        </p:nvSpPr>
-        <p:spPr>
-          <a:xfrm>
-            <a:off x="10382098" y="4279392"/>
-            <a:ext cx="22860" cy="274320"/>
-          </a:xfrm>
-          <a:prstGeom prst="rect">
-            <a:avLst/>
-          </a:prstGeom>
-          <a:solidFill>
-            <a:srgbClr val="C9CDD6"/>
-          </a:solidFill>
-          <a:ln/>
-        </p:spPr>
-      </p:sp>
-      <p:sp>
-        <p:nvSpPr>
-          <p:cNvPr id="26" name="Shape 23"/>
-          <p:cNvSpPr/>
-          <p:nvPr/>
-        </p:nvSpPr>
-        <p:spPr>
-          <a:xfrm>
-            <a:off x="9433408" y="4553712"/>
-            <a:ext cx="1920240" cy="841248"/>
-          </a:xfrm>
-          <a:prstGeom prst="roundRect">
-            <a:avLst>
-              <a:gd name="adj" fmla="val 8696"/>
-            </a:avLst>
-          </a:prstGeom>
-          <a:solidFill>
-            <a:srgbClr val="F4F5F8"/>
-          </a:solidFill>
-          <a:ln w="17780">
-            <a:solidFill>
-              <a:srgbClr val="C4BDFF"/>
-            </a:solidFill>
-            <a:prstDash val="solid"/>
-          </a:ln>
-        </p:spPr>
-      </p:sp>
-      <p:sp>
-        <p:nvSpPr>
-          <p:cNvPr id="27" name="Text 24"/>
-          <p:cNvSpPr txBox="1"/>
-          <p:nvPr/>
-        </p:nvSpPr>
-        <p:spPr>
-          <a:xfrm>
-            <a:off x="9433408" y="4553712"/>
-            <a:ext cx="1920240" cy="841248"/>
-          </a:xfrm>
-          <a:prstGeom prst="rect">
-            <a:avLst/>
-          </a:prstGeom>
-          <a:noFill/>
-          <a:ln/>
-        </p:spPr>
-        <p:txBody>
-          <a:bodyPr wrap="square" lIns="0" tIns="0" rIns="0" bIns="0" rtlCol="0" anchor="ctr"/>
-          <a:lstStyle/>
-          <a:p>
-            <a:pPr algn="ctr" indent="0" marL="0">
-              <a:lnSpc>
-                <a:spcPts val="1700"/>
-              </a:lnSpc>
-              <a:buNone/>
-            </a:pPr>
-            <a:r>
-              <a:rPr lang="en-US" sz="1350" b="1" dirty="0">
-                <a:solidFill>
-                  <a:srgbClr val="15171F"/>
-                </a:solidFill>
-                <a:latin typeface="Public Sans" pitchFamily="34" charset="0"/>
-                <a:ea typeface="Public Sans" pitchFamily="34" charset="-122"/>
-                <a:cs typeface="Public Sans" pitchFamily="34" charset="-120"/>
-              </a:rPr>
-              <a:t>Workflow</a:t>
-            </a:r>
-            <a:endParaRPr lang="en-US" sz="1350" dirty="0"/>
-          </a:p>
-          <a:p>
-            <a:pPr algn="ctr" indent="0" marL="0">
-              <a:lnSpc>
-                <a:spcPts val="1700"/>
-              </a:lnSpc>
-              <a:buNone/>
-            </a:pPr>
-            <a:r>
-              <a:rPr lang="en-US" sz="1350" b="1" dirty="0">
-                <a:solidFill>
-                  <a:srgbClr val="15171F"/>
-                </a:solidFill>
-                <a:latin typeface="Public Sans" pitchFamily="34" charset="0"/>
-                <a:ea typeface="Public Sans" pitchFamily="34" charset="-122"/>
-                <a:cs typeface="Public Sans" pitchFamily="34" charset="-120"/>
-              </a:rPr>
-              <a:t>Architect</a:t>
-            </a:r>
-            <a:endParaRPr lang="en-US" sz="1350" dirty="0"/>
-          </a:p>
-        </p:txBody>
-      </p:sp>
-      <p:sp>
-        <p:nvSpPr>
-          <p:cNvPr id="28" name="Text 25"/>
-          <p:cNvSpPr txBox="1"/>
-          <p:nvPr/>
-        </p:nvSpPr>
-        <p:spPr>
-          <a:xfrm>
-            <a:off x="777240" y="5623560"/>
-            <a:ext cx="10607040" cy="320040"/>
-          </a:xfrm>
-          <a:prstGeom prst="rect">
-            <a:avLst/>
-          </a:prstGeom>
-          <a:noFill/>
-          <a:ln/>
-        </p:spPr>
-        <p:txBody>
-          <a:bodyPr wrap="square" lIns="0" tIns="0" rIns="0" bIns="0" rtlCol="0" anchor="ctr"/>
-          <a:lstStyle/>
-          <a:p>
-            <a:pPr algn="ctr" indent="0" marL="0">
-              <a:buNone/>
-            </a:pPr>
-            <a:r>
-              <a:rPr lang="en-US" sz="1000" spc="100" kern="0" dirty="0">
+              <a:t>Add a department with an executive next month </a:t>
+            </a:r>
+            <a:pPr indent="0" marL="0">
+              <a:buNone/>
+            </a:pPr>
+            <a:r>
+              <a:rPr lang="en-US" sz="1400" dirty="0">
                 <a:solidFill>
                   <a:srgbClr val="5B6270"/>
                 </a:solidFill>
-                <a:latin typeface="Courier New" pitchFamily="34" charset="0"/>
-                <a:ea typeface="Courier New" pitchFamily="34" charset="-122"/>
-                <a:cs typeface="Courier New" pitchFamily="34" charset="-120"/>
-              </a:rPr>
-              <a:t>Four of them are parts of your job. The fifth keeps the writing itself honest.</a:t>
-            </a:r>
-            <a:endParaRPr lang="en-US" sz="1000" dirty="0"/>
-          </a:p>
-        </p:txBody>
-      </p:sp>
-      <p:sp>
-        <p:nvSpPr>
-          <p:cNvPr id="29" name="Text 26"/>
+                <a:latin typeface="Public Sans" pitchFamily="34" charset="0"/>
+                <a:ea typeface="Public Sans" pitchFamily="34" charset="-122"/>
+                <a:cs typeface="Public Sans" pitchFamily="34" charset="-120"/>
+              </a:rPr>
+              <a:t>— one sentence — and it appears here on the next build. There is no diagram to maintain.</a:t>
+            </a:r>
+            <a:endParaRPr lang="en-US" sz="1400" dirty="0"/>
+          </a:p>
+        </p:txBody>
+      </p:sp>
+      <p:sp>
+        <p:nvSpPr>
+          <p:cNvPr id="9" name="Text 5"/>
           <p:cNvSpPr txBox="1"/>
           <p:nvPr/>
         </p:nvSpPr>
@@ -5302,7 +4680,7 @@
                 <a:ea typeface="Public Sans" pitchFamily="34" charset="-122"/>
                 <a:cs typeface="Public Sans" pitchFamily="34" charset="-120"/>
               </a:rPr>
-              <a:t>Your departments, on the page, counted</a:t>
+              <a:t>Your workflows, in department blocks</a:t>
             </a:r>
             <a:endParaRPr lang="en-US" sz="3000" dirty="0"/>
           </a:p>
@@ -5344,7 +4722,7 @@
                 <a:ea typeface="Public Sans" pitchFamily="34" charset="-122"/>
                 <a:cs typeface="Public Sans" pitchFamily="34" charset="-120"/>
               </a:rPr>
-              <a:t>Nobody typed these numbers. They were counted off your own notes when the page was built.</a:t>
+              <a:t>Nobody typed these counts. They were counted off your own notes when the page was built.</a:t>
             </a:r>
             <a:endParaRPr lang="en-US" sz="1500" dirty="0"/>
           </a:p>
@@ -5352,7 +4730,7 @@
       </p:sp>
       <p:pic>
         <p:nvPicPr>
-          <p:cNvPr id="6" name="Image 1" descr="/tmp/claude-0/-home-claude/e62a35b1-5075-553d-b086-acebfebc41ba/scratchpad/deck/w-depts.png">    </p:cNvPr>
+          <p:cNvPr id="6" name="Image 1" descr="/tmp/claude-0/-home-claude/e62a35b1-5075-553d-b086-acebfebc41ba/scratchpad/deck/k-blocks.png">    </p:cNvPr>
           <p:cNvPicPr>
             <a:picLocks noChangeAspect="1"/>
           </p:cNvPicPr>
@@ -5366,8 +4744,8 @@
         </p:blipFill>
         <p:spPr>
           <a:xfrm>
-            <a:off x="777240" y="2286000"/>
-            <a:ext cx="10607040" cy="2642616"/>
+            <a:off x="777240" y="2194560"/>
+            <a:ext cx="10607040" cy="1764792"/>
           </a:xfrm>
           <a:prstGeom prst="rect">
             <a:avLst/>
@@ -5382,12 +4760,12 @@
         </p:nvSpPr>
         <p:spPr>
           <a:xfrm>
-            <a:off x="777240" y="5257800"/>
-            <a:ext cx="10607040" cy="640080"/>
+            <a:off x="777240" y="4251960"/>
+            <a:ext cx="5029200" cy="1645920"/>
           </a:xfrm>
           <a:prstGeom prst="roundRect">
             <a:avLst>
-              <a:gd name="adj" fmla="val 8571"/>
+              <a:gd name="adj" fmla="val 3333"/>
             </a:avLst>
           </a:prstGeom>
           <a:solidFill>
@@ -5409,24 +4787,66 @@
         </p:nvSpPr>
         <p:spPr>
           <a:xfrm>
-            <a:off x="1097280" y="5257800"/>
-            <a:ext cx="10058400" cy="640080"/>
-          </a:xfrm>
-          <a:prstGeom prst="rect">
-            <a:avLst/>
-          </a:prstGeom>
-          <a:noFill/>
-          <a:ln/>
-        </p:spPr>
-        <p:txBody>
-          <a:bodyPr wrap="square" lIns="0" tIns="0" rIns="0" bIns="0" rtlCol="0" anchor="ctr"/>
-          <a:lstStyle/>
-          <a:p>
-            <a:pPr indent="0" marL="0">
-              <a:buNone/>
-            </a:pPr>
-            <a:r>
-              <a:rPr lang="en-US" sz="1450" b="1" dirty="0">
+            <a:off x="1051560" y="4526280"/>
+            <a:ext cx="4480560" cy="219456"/>
+          </a:xfrm>
+          <a:prstGeom prst="rect">
+            <a:avLst/>
+          </a:prstGeom>
+          <a:noFill/>
+          <a:ln/>
+        </p:spPr>
+        <p:txBody>
+          <a:bodyPr wrap="square" lIns="0" tIns="0" rIns="0" bIns="0" rtlCol="0" anchor="ctr"/>
+          <a:lstStyle/>
+          <a:p>
+            <a:pPr indent="0" marL="0">
+              <a:buNone/>
+            </a:pPr>
+            <a:r>
+              <a:rPr lang="en-US" sz="950" spc="140" kern="0" dirty="0">
+                <a:solidFill>
+                  <a:srgbClr val="7367F0"/>
+                </a:solidFill>
+                <a:latin typeface="Courier New" pitchFamily="34" charset="0"/>
+                <a:ea typeface="Courier New" pitchFamily="34" charset="-122"/>
+                <a:cs typeface="Courier New" pitchFamily="34" charset="-120"/>
+              </a:rPr>
+              <a:t>ONE BLOCK PER DEPARTMENT</a:t>
+            </a:r>
+            <a:endParaRPr lang="en-US" sz="950" dirty="0"/>
+          </a:p>
+        </p:txBody>
+      </p:sp>
+      <p:sp>
+        <p:nvSpPr>
+          <p:cNvPr id="9" name="Text 5"/>
+          <p:cNvSpPr txBox="1"/>
+          <p:nvPr/>
+        </p:nvSpPr>
+        <p:spPr>
+          <a:xfrm>
+            <a:off x="1051560" y="4818888"/>
+            <a:ext cx="4480560" cy="347472"/>
+          </a:xfrm>
+          <a:prstGeom prst="rect">
+            <a:avLst/>
+          </a:prstGeom>
+          <a:noFill/>
+          <a:ln/>
+        </p:spPr>
+        <p:txBody>
+          <a:bodyPr wrap="square" lIns="0" tIns="0" rIns="0" bIns="0" rtlCol="0" anchor="t"/>
+          <a:lstStyle/>
+          <a:p>
+            <a:pPr indent="0" marL="0">
+              <a:lnSpc>
+                <a:spcPts val="1920"/>
+              </a:lnSpc>
+              <a:buNone/>
+            </a:pPr>
+            <a:r>
+              <a:rPr lang="en-US" sz="1600" b="1" dirty="0">
                 <a:solidFill>
                   <a:srgbClr val="15171F"/>
                 </a:solidFill>
@@ -5434,13 +4854,41 @@
                 <a:ea typeface="Public Sans" pitchFamily="34" charset="-122"/>
                 <a:cs typeface="Public Sans" pitchFamily="34" charset="-120"/>
               </a:rPr>
-              <a:t>“LinkedIn &amp; Social — 1 workflow, 0 running.” </a:t>
-            </a:r>
-            <a:pPr indent="0" marL="0">
-              <a:buNone/>
-            </a:pPr>
-            <a:r>
-              <a:rPr lang="en-US" sz="1450" dirty="0">
+              <a:t>Everything lands somewhere</a:t>
+            </a:r>
+            <a:endParaRPr lang="en-US" sz="1600" dirty="0"/>
+          </a:p>
+        </p:txBody>
+      </p:sp>
+      <p:sp>
+        <p:nvSpPr>
+          <p:cNvPr id="10" name="Text 6"/>
+          <p:cNvSpPr txBox="1"/>
+          <p:nvPr/>
+        </p:nvSpPr>
+        <p:spPr>
+          <a:xfrm>
+            <a:off x="1051560" y="5257800"/>
+            <a:ext cx="4480560" cy="402336"/>
+          </a:xfrm>
+          <a:prstGeom prst="rect">
+            <a:avLst/>
+          </a:prstGeom>
+          <a:noFill/>
+          <a:ln/>
+        </p:spPr>
+        <p:txBody>
+          <a:bodyPr wrap="square" lIns="0" tIns="0" rIns="0" bIns="0" rtlCol="0" anchor="t"/>
+          <a:lstStyle/>
+          <a:p>
+            <a:pPr indent="0" marL="0">
+              <a:lnSpc>
+                <a:spcPts val="1846"/>
+              </a:lnSpc>
+              <a:buNone/>
+            </a:pPr>
+            <a:r>
+              <a:rPr lang="en-US" sz="1300" dirty="0">
                 <a:solidFill>
                   <a:srgbClr val="5B6270"/>
                 </a:solidFill>
@@ -5448,15 +4896,165 @@
                 <a:ea typeface="Public Sans" pitchFamily="34" charset="-122"/>
                 <a:cs typeface="Public Sans" pitchFamily="34" charset="-120"/>
               </a:rPr>
-              <a:t>Uncomfortable, true, and you did not have to admit it.</a:t>
-            </a:r>
-            <a:endParaRPr lang="en-US" sz="1450" dirty="0"/>
-          </a:p>
-        </p:txBody>
-      </p:sp>
-      <p:sp>
-        <p:nvSpPr>
-          <p:cNvPr id="9" name="Text 5"/>
+              <a:t>A workflow names its department or it fails the check. Nothing drifts into a pile nobody owns.</a:t>
+            </a:r>
+            <a:endParaRPr lang="en-US" sz="1300" dirty="0"/>
+          </a:p>
+        </p:txBody>
+      </p:sp>
+      <p:sp>
+        <p:nvSpPr>
+          <p:cNvPr id="11" name="Shape 7"/>
+          <p:cNvSpPr/>
+          <p:nvPr/>
+        </p:nvSpPr>
+        <p:spPr>
+          <a:xfrm>
+            <a:off x="6172200" y="4251960"/>
+            <a:ext cx="5029200" cy="1645920"/>
+          </a:xfrm>
+          <a:prstGeom prst="roundRect">
+            <a:avLst>
+              <a:gd name="adj" fmla="val 3333"/>
+            </a:avLst>
+          </a:prstGeom>
+          <a:solidFill>
+            <a:srgbClr val="F4F5F8"/>
+          </a:solidFill>
+          <a:ln w="12700">
+            <a:solidFill>
+              <a:srgbClr val="E4E6EC"/>
+            </a:solidFill>
+            <a:prstDash val="solid"/>
+          </a:ln>
+        </p:spPr>
+      </p:sp>
+      <p:sp>
+        <p:nvSpPr>
+          <p:cNvPr id="12" name="Text 8"/>
+          <p:cNvSpPr txBox="1"/>
+          <p:nvPr/>
+        </p:nvSpPr>
+        <p:spPr>
+          <a:xfrm>
+            <a:off x="6446520" y="4526280"/>
+            <a:ext cx="4480560" cy="219456"/>
+          </a:xfrm>
+          <a:prstGeom prst="rect">
+            <a:avLst/>
+          </a:prstGeom>
+          <a:noFill/>
+          <a:ln/>
+        </p:spPr>
+        <p:txBody>
+          <a:bodyPr wrap="square" lIns="0" tIns="0" rIns="0" bIns="0" rtlCol="0" anchor="ctr"/>
+          <a:lstStyle/>
+          <a:p>
+            <a:pPr indent="0" marL="0">
+              <a:buNone/>
+            </a:pPr>
+            <a:r>
+              <a:rPr lang="en-US" sz="950" spc="140" kern="0" dirty="0">
+                <a:solidFill>
+                  <a:srgbClr val="7367F0"/>
+                </a:solidFill>
+                <a:latin typeface="Courier New" pitchFamily="34" charset="0"/>
+                <a:ea typeface="Courier New" pitchFamily="34" charset="-122"/>
+                <a:cs typeface="Courier New" pitchFamily="34" charset="-120"/>
+              </a:rPr>
+              <a:t>THE NUMBER TO LOOK AT</a:t>
+            </a:r>
+            <a:endParaRPr lang="en-US" sz="950" dirty="0"/>
+          </a:p>
+        </p:txBody>
+      </p:sp>
+      <p:sp>
+        <p:nvSpPr>
+          <p:cNvPr id="13" name="Text 9"/>
+          <p:cNvSpPr txBox="1"/>
+          <p:nvPr/>
+        </p:nvSpPr>
+        <p:spPr>
+          <a:xfrm>
+            <a:off x="6446520" y="4818888"/>
+            <a:ext cx="4480560" cy="347472"/>
+          </a:xfrm>
+          <a:prstGeom prst="rect">
+            <a:avLst/>
+          </a:prstGeom>
+          <a:noFill/>
+          <a:ln/>
+        </p:spPr>
+        <p:txBody>
+          <a:bodyPr wrap="square" lIns="0" tIns="0" rIns="0" bIns="0" rtlCol="0" anchor="t"/>
+          <a:lstStyle/>
+          <a:p>
+            <a:pPr indent="0" marL="0">
+              <a:lnSpc>
+                <a:spcPts val="1920"/>
+              </a:lnSpc>
+              <a:buNone/>
+            </a:pPr>
+            <a:r>
+              <a:rPr lang="en-US" sz="1600" b="1" dirty="0">
+                <a:solidFill>
+                  <a:srgbClr val="15171F"/>
+                </a:solidFill>
+                <a:latin typeface="Public Sans" pitchFamily="34" charset="0"/>
+                <a:ea typeface="Public Sans" pitchFamily="34" charset="-122"/>
+                <a:cs typeface="Public Sans" pitchFamily="34" charset="-120"/>
+              </a:rPr>
+              <a:t>One workflow, none running</a:t>
+            </a:r>
+            <a:endParaRPr lang="en-US" sz="1600" dirty="0"/>
+          </a:p>
+        </p:txBody>
+      </p:sp>
+      <p:sp>
+        <p:nvSpPr>
+          <p:cNvPr id="14" name="Text 10"/>
+          <p:cNvSpPr txBox="1"/>
+          <p:nvPr/>
+        </p:nvSpPr>
+        <p:spPr>
+          <a:xfrm>
+            <a:off x="6446520" y="5257800"/>
+            <a:ext cx="4480560" cy="402336"/>
+          </a:xfrm>
+          <a:prstGeom prst="rect">
+            <a:avLst/>
+          </a:prstGeom>
+          <a:noFill/>
+          <a:ln/>
+        </p:spPr>
+        <p:txBody>
+          <a:bodyPr wrap="square" lIns="0" tIns="0" rIns="0" bIns="0" rtlCol="0" anchor="t"/>
+          <a:lstStyle/>
+          <a:p>
+            <a:pPr indent="0" marL="0">
+              <a:lnSpc>
+                <a:spcPts val="1846"/>
+              </a:lnSpc>
+              <a:buNone/>
+            </a:pPr>
+            <a:r>
+              <a:rPr lang="en-US" sz="1300" dirty="0">
+                <a:solidFill>
+                  <a:srgbClr val="5B6270"/>
+                </a:solidFill>
+                <a:latin typeface="Public Sans" pitchFamily="34" charset="0"/>
+                <a:ea typeface="Public Sans" pitchFamily="34" charset="-122"/>
+                <a:cs typeface="Public Sans" pitchFamily="34" charset="-120"/>
+              </a:rPr>
+              <a:t>Uncomfortable, true, and you did not have to admit it. It was counted, not reported.</a:t>
+            </a:r>
+            <a:endParaRPr lang="en-US" sz="1300" dirty="0"/>
+          </a:p>
+        </p:txBody>
+      </p:sp>
+      <p:sp>
+        <p:nvSpPr>
+          <p:cNvPr id="15" name="Text 11"/>
           <p:cNvSpPr txBox="1"/>
           <p:nvPr/>
         </p:nvSpPr>
@@ -11827,7 +11425,7 @@
                 <a:ea typeface="Public Sans" pitchFamily="34" charset="-122"/>
                 <a:cs typeface="Public Sans" pitchFamily="34" charset="-120"/>
               </a:rPr>
-              <a:t>Claude reports back what it made — folders, a contract, agents, workflows and a page.</a:t>
+              <a:t>Claude reports back what it made — folders, a contract, working agents, workflows and a four-page site.</a:t>
             </a:r>
             <a:endParaRPr lang="en-US" sz="1450" dirty="0"/>
           </a:p>
@@ -11930,19 +11528,33 @@
         </p:nvSpPr>
         <p:spPr>
           <a:xfrm>
-            <a:off x="777240" y="5623560"/>
-            <a:ext cx="10607040" cy="320040"/>
-          </a:xfrm>
-          <a:prstGeom prst="rect">
-            <a:avLst/>
-          </a:prstGeom>
-          <a:noFill/>
-          <a:ln/>
-        </p:spPr>
-        <p:txBody>
-          <a:bodyPr wrap="square" lIns="0" tIns="0" rIns="0" bIns="0" rtlCol="0" anchor="ctr"/>
-          <a:lstStyle/>
-          <a:p>
+            <a:off x="777240" y="5596128"/>
+            <a:ext cx="10607040" cy="365760"/>
+          </a:xfrm>
+          <a:prstGeom prst="rect">
+            <a:avLst/>
+          </a:prstGeom>
+          <a:noFill/>
+          <a:ln/>
+        </p:spPr>
+        <p:txBody>
+          <a:bodyPr wrap="square" lIns="0" tIns="0" rIns="0" bIns="0" rtlCol="0" anchor="ctr"/>
+          <a:lstStyle/>
+          <a:p>
+            <a:pPr indent="0" marL="0">
+              <a:buNone/>
+            </a:pPr>
+            <a:r>
+              <a:rPr lang="en-US" sz="1350" b="1" dirty="0">
+                <a:solidFill>
+                  <a:srgbClr val="FFFFFF"/>
+                </a:solidFill>
+                <a:latin typeface="Public Sans" pitchFamily="34" charset="0"/>
+                <a:ea typeface="Public Sans" pitchFamily="34" charset="-122"/>
+                <a:cs typeface="Public Sans" pitchFamily="34" charset="-120"/>
+              </a:rPr>
+              <a:t>It will ask you one question: what to call your executives. </a:t>
+            </a:r>
             <a:pPr indent="0" marL="0">
               <a:buNone/>
             </a:pPr>
@@ -11955,7 +11567,7 @@
                 <a:ea typeface="Public Sans" pitchFamily="34" charset="-122"/>
                 <a:cs typeface="Public Sans" pitchFamily="34" charset="-120"/>
               </a:rPr>
-              <a:t>Or your own words — it is read for intent, not matched against a format.</a:t>
+              <a:t>Job titles, Norse gods, Friends, the Kardashians — or three names of your own.</a:t>
             </a:r>
             <a:endParaRPr lang="en-US" sz="1350" dirty="0"/>
           </a:p>

</xml_diff>